<commit_message>
decks: Lesson 1 Day 1, with today's free-tier join flow
All 13 of Brian's slides. His own Two Truths and a Lie slides stay, with
notes telling teachers to make their own the same way or delete them.
His old sign-up screenshot becomes three slides of the current join
flow: the class's Students-tab join link (address shown as yawp.school,
QR blurred), the student "Create your student account" page, and the
dashboard they land on. The elephant photo moves to JPEG (4 MB -> 0.6 MB).

Co-Authored-By: Claude Opus 5.5 <noreply@anthropic.com>
Claude-Session: https://claude.ai/code/session_01UdRZiPuGfgyCyhqFn7imqw
</commit_message>
<xml_diff>
--- a/services/web-app/resources/thesis-essay-decks/lesson-2-pre-writing.pptx
+++ b/services/web-app/resources/thesis-essay-decks/lesson-2-pre-writing.pptx
@@ -4044,7 +4044,7 @@
               <a:buNone/>
             </a:pPr>
             <a:r>
-              <a:rPr lang="en-US" sz="2600" dirty="0">
+              <a:rPr lang="en-US" sz="2300" dirty="0">
                 <a:solidFill>
                   <a:srgbClr val="3C3828"/>
                 </a:solidFill>
@@ -4054,7 +4054,7 @@
               </a:rPr>
               <a:t>Without it, your essay might be rambling and disorganized</a:t>
             </a:r>
-            <a:endParaRPr lang="en-US" sz="2600" dirty="0"/>
+            <a:endParaRPr lang="en-US" sz="2300" dirty="0"/>
           </a:p>
         </p:txBody>
       </p:sp>
@@ -4206,7 +4206,7 @@
               <a:buNone/>
             </a:pPr>
             <a:r>
-              <a:rPr lang="en-US" sz="2600" dirty="0">
+              <a:rPr lang="en-US" sz="2300" dirty="0">
                 <a:solidFill>
                   <a:srgbClr val="3C3828"/>
                 </a:solidFill>
@@ -4216,7 +4216,7 @@
               </a:rPr>
               <a:t>Great thesis statements lead to great essays</a:t>
             </a:r>
-            <a:endParaRPr lang="en-US" sz="2600" dirty="0"/>
+            <a:endParaRPr lang="en-US" sz="2300" dirty="0"/>
           </a:p>
         </p:txBody>
       </p:sp>
@@ -4368,7 +4368,7 @@
               <a:buNone/>
             </a:pPr>
             <a:r>
-              <a:rPr lang="en-US" sz="2600" dirty="0">
+              <a:rPr lang="en-US" sz="2300" dirty="0">
                 <a:solidFill>
                   <a:srgbClr val="3C3828"/>
                 </a:solidFill>
@@ -4381,7 +4381,7 @@
               </a:rPr>
               <a:t>Don’t ever start an essay until you know what you’re going to say!</a:t>
             </a:r>
-            <a:endParaRPr lang="en-US" sz="2600" dirty="0"/>
+            <a:endParaRPr lang="en-US" sz="2300" dirty="0"/>
           </a:p>
         </p:txBody>
       </p:sp>

</xml_diff>